<commit_message>
Rebuild literature survey, inferences and references around the supplied papers
Base paper (CBFISKD) plus nine supplied keylogger, explainable-malware,
ransomware, ATT&CK-mapping and API-sequence papers; references updated.

Co-Authored-By: Claude Sonnet 5.5 <noreply@anthropic.com>
Claude-Session: https://claude.ai/code/session_01Ubm72VtBiHpqSsRzfmreab
</commit_message>
<xml_diff>
--- a/presentation/Keyboard_Hook_Behavioral_Detector.pptx
+++ b/presentation/Keyboard_Hook_Behavioral_Detector.pptx
@@ -136,23 +136,23 @@
   <p:extLst>
     <p:ext uri="{521415D9-36F7-43E2-AB2F-B90AF26B5E84}">
       <p14:sectionLst xmlns:p14="http://schemas.microsoft.com/office/powerpoint/2010/main">
-        <p14:section name="Title" id="{ca5f4eac-b618-bd54-38a7-04d493d91831}">
+        <p14:section name="Title" id="{4fa8eb9d-cb60-a882-3217-d80e26b886e8}">
           <p14:sldIdLst>
             <p14:sldId id="256"/>
             <p14:sldId id="257"/>
           </p14:sldIdLst>
         </p14:section>
-        <p14:section name="Introduction" id="{85187d10-ec71-e659-9d48-d87ecd8945b8}">
+        <p14:section name="Introduction" id="{4acf0f3a-e43c-266e-bd47-f17979f9e925}">
           <p14:sldIdLst>
             <p14:sldId id="258"/>
           </p14:sldIdLst>
         </p14:section>
-        <p14:section name="Problem Definition" id="{8df79e76-4ce5-be65-ed1c-b13787bb6544}">
+        <p14:section name="Problem Definition" id="{6677f4b3-2aca-c6ab-c0c8-95dce31100e2}">
           <p14:sldIdLst>
             <p14:sldId id="259"/>
           </p14:sldIdLst>
         </p14:section>
-        <p14:section name="Literature Survey" id="{2428ff5c-8ef2-14dd-53e3-938f23e28033}">
+        <p14:section name="Literature Survey" id="{87f261ed-7090-b709-b440-9cce3bb98637}">
           <p14:sldIdLst>
             <p14:sldId id="260"/>
             <p14:sldId id="261"/>
@@ -161,31 +161,31 @@
             <p14:sldId id="264"/>
           </p14:sldIdLst>
         </p14:section>
-        <p14:section name="Inferences" id="{ab2d6f93-261d-33ec-9743-70ecc1ec6541}">
+        <p14:section name="Inferences" id="{b14ec87e-897c-b7a3-97af-8a1b208658a6}">
           <p14:sldIdLst>
             <p14:sldId id="265"/>
           </p14:sldIdLst>
         </p14:section>
-        <p14:section name="Proposed System" id="{1489614a-4f95-6f2a-9474-ffc429f1683b}">
+        <p14:section name="Proposed System" id="{71048406-da41-4a54-f065-d60ace0f59fd}">
           <p14:sldIdLst>
             <p14:sldId id="266"/>
             <p14:sldId id="267"/>
           </p14:sldIdLst>
         </p14:section>
-        <p14:section name="Architecture" id="{0caf587c-f262-1462-bf9a-a417a56c2144}">
+        <p14:section name="Architecture" id="{3ecb5f1c-a4b8-e85f-5c10-5f0e2df5f8a4}">
           <p14:sldIdLst>
             <p14:sldId id="268"/>
             <p14:sldId id="269"/>
           </p14:sldIdLst>
         </p14:section>
-        <p14:section name="Implementation" id="{4e386603-fb23-75b8-0693-4dfe4a44aff5}">
+        <p14:section name="Implementation" id="{61de55c8-d2c6-c9f3-8032-4d23934d0fb3}">
           <p14:sldIdLst>
             <p14:sldId id="270"/>
             <p14:sldId id="271"/>
             <p14:sldId id="272"/>
           </p14:sldIdLst>
         </p14:section>
-        <p14:section name="Results and Discussions" id="{4fd66c17-f8b0-2f70-4cd2-05f1f8f21fd4}">
+        <p14:section name="Results and Discussions" id="{eebaa726-0b16-22c2-377d-40eedc5a023e}">
           <p14:sldIdLst>
             <p14:sldId id="273"/>
             <p14:sldId id="274"/>
@@ -197,14 +197,14 @@
             <p14:sldId id="280"/>
           </p14:sldIdLst>
         </p14:section>
-        <p14:section name="References" id="{699774ea-a01a-9007-ce99-f5abc35fdf59}">
+        <p14:section name="References" id="{96be746b-2fb4-a440-80e0-8969034086a2}">
           <p14:sldIdLst>
             <p14:sldId id="281"/>
             <p14:sldId id="282"/>
             <p14:sldId id="283"/>
           </p14:sldIdLst>
         </p14:section>
-        <p14:section name="Conclusion" id="{c2381ac1-3e70-1247-36af-c6b203281d0a}">
+        <p14:section name="Conclusion" id="{8e8a139a-2ec8-0fe4-8113-09991cf83a14}">
           <p14:sldIdLst>
             <p14:sldId id="284"/>
             <p14:sldId id="285"/>
@@ -5159,14 +5159,14 @@
               <a:buChar char="•"/>
             </a:pPr>
             <a:r>
-              <a:rPr lang="en-US" sz="2400" dirty="0">
+              <a:rPr lang="en-US" sz="1900" dirty="0">
                 <a:solidFill>
                   <a:schemeClr val="tx1"/>
                 </a:solidFill>
               </a:rPr>
-              <a:t>Dynamic keylogger detectors work but are intrusive and heavy for always-on use, so a passive, read-only, user-mode approach is preferred.</a:t>
+              <a:t>Keylogger-detection research reports high accuracy (99.76% and 99.8%) with ML, ensembles and fuzzy rules, but on curated datasets or network features rather than live per-process monitoring [1]-[4].</a:t>
             </a:r>
-            <a:endParaRPr lang="en-US" sz="2400" dirty="0"/>
+            <a:endParaRPr lang="en-US" sz="1900" dirty="0"/>
           </a:p>
           <a:p>
             <a:pPr algn="just" marL="342900" indent="-342900">
@@ -5180,14 +5180,14 @@
               <a:buChar char="•"/>
             </a:pPr>
             <a:r>
-              <a:rPr lang="en-US" sz="2400" dirty="0">
+              <a:rPr lang="en-US" sz="1900" dirty="0">
                 <a:solidFill>
                   <a:schemeClr val="tx1"/>
                 </a:solidFill>
               </a:rPr>
-              <a:t>Static ML on PE features is accurate for malware in general but is not keylogger-specific; an import-table fingerprint mapped to MITRE ATT&amp;CK fills that gap.</a:t>
+              <a:t>Explainability is now expected: SHAP, LIME, logic rules and GNNExplainer are used to justify decisions [2], [5], [6], [8]. This motivates an explainable score built from named events and APIs.</a:t>
             </a:r>
-            <a:endParaRPr lang="en-US" sz="2400" dirty="0"/>
+            <a:endParaRPr lang="en-US" sz="1900" dirty="0"/>
           </a:p>
           <a:p>
             <a:pPr algn="just" marL="342900" indent="-342900">
@@ -5201,14 +5201,14 @@
               <a:buChar char="•"/>
             </a:pPr>
             <a:r>
-              <a:rPr lang="en-US" sz="2400" dirty="0">
+              <a:rPr lang="en-US" sz="1900" dirty="0">
                 <a:solidFill>
                   <a:schemeClr val="tx1"/>
                 </a:solidFill>
               </a:rPr>
-              <a:t>Single-snapshot verdicts and black-box scores are hard to trust; scoring over time with an explainable rule engine addresses this.</a:t>
+              <a:t>Hybrid static and dynamic analysis improves detection but is costly (about 9.1 s per sample in [8]); light static evidence plus temporal observation keeps a monitor cheap.</a:t>
             </a:r>
-            <a:endParaRPr lang="en-US" sz="2400" dirty="0"/>
+            <a:endParaRPr lang="en-US" sz="1900" dirty="0"/>
           </a:p>
           <a:p>
             <a:pPr algn="just" marL="342900" indent="-342900">
@@ -5222,14 +5222,35 @@
               <a:buChar char="•"/>
             </a:pPr>
             <a:r>
-              <a:rPr lang="en-US" sz="2400" dirty="0">
+              <a:rPr lang="en-US" sz="1900" dirty="0">
                 <a:solidFill>
                   <a:schemeClr val="tx1"/>
                 </a:solidFill>
               </a:rPr>
-              <a:t>Hook capability is common in benign software, so ML evidence should only amplify a rule-based trigger, supported by an allowlist and risk decay.</a:t>
+              <a:t>API-based static features are efficient and interpretable (sub-millisecond inference, 95.35% accuracy in [10]), which supports the import-table fingerprint.</a:t>
             </a:r>
-            <a:endParaRPr lang="en-US" sz="2400" dirty="0"/>
+            <a:endParaRPr lang="en-US" sz="1900" dirty="0"/>
+          </a:p>
+          <a:p>
+            <a:pPr algn="just" marL="342900" indent="-342900">
+              <a:lnSpc>
+                <a:spcPct val="105000"/>
+              </a:lnSpc>
+              <a:spcAft>
+                <a:spcPts val="1200"/>
+              </a:spcAft>
+              <a:buSzPct val="100000"/>
+              <a:buChar char="•"/>
+            </a:pPr>
+            <a:r>
+              <a:rPr lang="en-US" sz="1900" dirty="0">
+                <a:solidFill>
+                  <a:schemeClr val="tx1"/>
+                </a:solidFill>
+              </a:rPr>
+              <a:t>Mapping evidence to MITRE ATT&amp;CK gives a common vocabulary [9]; pattern-based detectors may miss unseen patterns [1], so ML and temporal persistence are added.</a:t>
+            </a:r>
+            <a:endParaRPr lang="en-US" sz="1900" dirty="0"/>
           </a:p>
         </p:txBody>
       </p:sp>
@@ -18708,14 +18729,14 @@
               <a:buNone/>
             </a:pPr>
             <a:r>
-              <a:rPr lang="en-US" sz="1900" dirty="0">
+              <a:rPr lang="en-US" sz="1800" dirty="0">
                 <a:solidFill>
                   <a:schemeClr val="tx1"/>
                 </a:solidFill>
               </a:rPr>
-              <a:t>[1] Ortolani, S., Giuffrida, C., &amp; Crispo, B. (2010). Bait your hook: a novel detection technique for keyloggers. Recent Advances in Intrusion Detection (RAID 2010), Springer.</a:t>
+              <a:t>[1] Ayo, F. E., Awotunde, J. B., Olalekan, O. A., Imoize, A. L., Li, C.-T., &amp; Lee, C.-C. (2023). CBFISKD: a combinatorial-based fuzzy inference system for keylogger detection. Mathematics, 11(8), 1899. https://www.mdpi.com/2227-7390/11/8/1899</a:t>
             </a:r>
-            <a:endParaRPr lang="en-US" sz="1900" dirty="0"/>
+            <a:endParaRPr lang="en-US" sz="1800" dirty="0"/>
           </a:p>
           <a:p>
             <a:pPr algn="l" indent="0" marL="0">
@@ -18725,14 +18746,14 @@
               <a:buNone/>
             </a:pPr>
             <a:r>
-              <a:rPr lang="en-US" sz="1900" dirty="0">
+              <a:rPr lang="en-US" sz="1800" dirty="0">
                 <a:solidFill>
                   <a:schemeClr val="tx1"/>
                 </a:solidFill>
               </a:rPr>
-              <a:t>[2] Ortolani, S., Giuffrida, C., &amp; Crispo, B. (2011). KLIMAX: profiling memory write patterns to detect keystroke-harvesting malware. Recent Advances in Intrusion Detection (RAID 2011), Springer.</a:t>
+              <a:t>[2] Mahmud, M. I. (2025). Towards trustworthy keylogger detection: a comprehensive analysis of ensemble techniques and feature selections through explainable AI. arXiv:2505.16103. https://arxiv.org/abs/2505.16103</a:t>
             </a:r>
-            <a:endParaRPr lang="en-US" sz="1900" dirty="0"/>
+            <a:endParaRPr lang="en-US" sz="1800" dirty="0"/>
           </a:p>
           <a:p>
             <a:pPr algn="l" indent="0" marL="0">
@@ -18742,14 +18763,14 @@
               <a:buNone/>
             </a:pPr>
             <a:r>
-              <a:rPr lang="en-US" sz="1900" dirty="0">
+              <a:rPr lang="en-US" sz="1800" dirty="0">
                 <a:solidFill>
                   <a:schemeClr val="tx1"/>
                 </a:solidFill>
               </a:rPr>
-              <a:t>[3] Kolbitsch, C., Comparetti, P. M., Kruegel, C., Kirda, E., Zhou, X., &amp; Wang, X. (2009). Effective and efficient malware detection at the end host. USENIX Security Symposium.</a:t>
+              <a:t>[3] Chinchalkar, S. P., &amp; Somkunwar, R. K. (2024). An innovative keylogger detection system using machine learning algorithms and dendritic cell algorithm. Revue d'Intelligence Artificielle, 38, 269-275. https://doi.org/10.18280/ria.380128</a:t>
             </a:r>
-            <a:endParaRPr lang="en-US" sz="1900" dirty="0"/>
+            <a:endParaRPr lang="en-US" sz="1800" dirty="0"/>
           </a:p>
           <a:p>
             <a:pPr algn="l" indent="0" marL="0">
@@ -18759,14 +18780,14 @@
               <a:buNone/>
             </a:pPr>
             <a:r>
-              <a:rPr lang="en-US" sz="1900" dirty="0">
+              <a:rPr lang="en-US" sz="1800" dirty="0">
                 <a:solidFill>
                   <a:schemeClr val="tx1"/>
                 </a:solidFill>
               </a:rPr>
-              <a:t>[4] Egele, M., Scholte, T., Kirda, E., &amp; Kruegel, C. (2012). A survey on automated dynamic malware-analysis techniques and tools. ACM Computing Surveys, 44(2).</a:t>
+              <a:t>[4] Maz, Y. A., Anbar, M., Manickam, S., Rihan, S. D. A., Alabsi, B. A., &amp; Dorgham, O. M. (2024). Majority voting ensemble classifier for detecting keylogging attack on Internet of Things. IEEE Access, 12, 19860-19871. https://doi.org/10.1109/ACCESS.2024.3362232</a:t>
             </a:r>
-            <a:endParaRPr lang="en-US" sz="1900" dirty="0"/>
+            <a:endParaRPr lang="en-US" sz="1800" dirty="0"/>
           </a:p>
           <a:p>
             <a:pPr algn="l" indent="0" marL="0">
@@ -18776,14 +18797,14 @@
               <a:buNone/>
             </a:pPr>
             <a:r>
-              <a:rPr lang="en-US" sz="1900" dirty="0">
+              <a:rPr lang="en-US" sz="1800" dirty="0">
                 <a:solidFill>
                   <a:schemeClr val="tx1"/>
                 </a:solidFill>
               </a:rPr>
-              <a:t>[5] Moser, A., Kruegel, C., &amp; Kirda, E. (2007). Limits of static analysis for malware detection. Annual Computer Security Applications Conference (ACSAC).</a:t>
+              <a:t>[5] Anthony, P., Giannini, F., Diligenti, M., Homola, M., Gori, M., Balogh, S., &amp; Mojzis, J. (2024). Explainable malware detection with tailored logic explained networks. arXiv:2405.03009. https://arxiv.org/abs/2405.03009</a:t>
             </a:r>
-            <a:endParaRPr lang="en-US" sz="1900" dirty="0"/>
+            <a:endParaRPr lang="en-US" sz="1800" dirty="0"/>
           </a:p>
         </p:txBody>
       </p:sp>
@@ -18923,14 +18944,14 @@
               <a:buNone/>
             </a:pPr>
             <a:r>
-              <a:rPr lang="en-US" sz="1900" dirty="0">
+              <a:rPr lang="en-US" sz="1800" dirty="0">
                 <a:solidFill>
                   <a:schemeClr val="tx1"/>
                 </a:solidFill>
               </a:rPr>
-              <a:t>[6] Shafiq, M. Z., Tabish, S. M., Mirza, F., &amp; Farooq, M. (2009). PE-Miner: mining structural information to detect malicious executables in realtime. Recent Advances in Intrusion Detection (RAID 2009), Springer.</a:t>
+              <a:t>[6] Mohammadian, H., Higgins, G., Ansong, S., Razavi-Far, R., &amp; Ghorbani, A. A. (2024). Explainable malware detection through integrated graph reduction and learning techniques. arXiv:2412.03634. https://arxiv.org/abs/2412.03634</a:t>
             </a:r>
-            <a:endParaRPr lang="en-US" sz="1900" dirty="0"/>
+            <a:endParaRPr lang="en-US" sz="1800" dirty="0"/>
           </a:p>
           <a:p>
             <a:pPr algn="l" indent="0" marL="0">
@@ -18940,14 +18961,14 @@
               <a:buNone/>
             </a:pPr>
             <a:r>
-              <a:rPr lang="en-US" sz="1900" dirty="0">
+              <a:rPr lang="en-US" sz="1800" dirty="0">
                 <a:solidFill>
                   <a:schemeClr val="tx1"/>
                 </a:solidFill>
               </a:rPr>
-              <a:t>[7] Saxe, J., &amp; Berlin, K. (2015). Deep neural network based malware detection using two dimensional binary program features. arXiv:1508.03096.</a:t>
+              <a:t>[7] Azugo, P., Venter, H., &amp; Wa Nkongolo, M. (2024). Ransomware detection and classification using random forest: a case study with the UGRansome2024 dataset. arXiv:2404.12855. https://arxiv.org/abs/2404.12855</a:t>
             </a:r>
-            <a:endParaRPr lang="en-US" sz="1900" dirty="0"/>
+            <a:endParaRPr lang="en-US" sz="1800" dirty="0"/>
           </a:p>
           <a:p>
             <a:pPr algn="l" indent="0" marL="0">
@@ -18957,14 +18978,14 @@
               <a:buNone/>
             </a:pPr>
             <a:r>
-              <a:rPr lang="en-US" sz="1900" dirty="0">
+              <a:rPr lang="en-US" sz="1800" dirty="0">
                 <a:solidFill>
                   <a:schemeClr val="tx1"/>
                 </a:solidFill>
               </a:rPr>
-              <a:t>[8] Raff, E., Barker, J., Sylvester, J., Brandon, R., Catanzaro, B., &amp; Nicholas, C. (2018). Malware detection by eating a whole EXE. arXiv:1710.09435.</a:t>
+              <a:t>[8] Caliskan, B., Gulatas, I., Kilinc, H. H., &amp; Zaim, A. H. (2026). RansomTrack: a hybrid behavioral analysis framework for ransomware detection. arXiv:2604.08739. https://arxiv.org/abs/2604.08739</a:t>
             </a:r>
-            <a:endParaRPr lang="en-US" sz="1900" dirty="0"/>
+            <a:endParaRPr lang="en-US" sz="1800" dirty="0"/>
           </a:p>
           <a:p>
             <a:pPr algn="l" indent="0" marL="0">
@@ -18974,14 +18995,14 @@
               <a:buNone/>
             </a:pPr>
             <a:r>
-              <a:rPr lang="en-US" sz="1900" dirty="0">
+              <a:rPr lang="en-US" sz="1800" dirty="0">
                 <a:solidFill>
                   <a:schemeClr val="tx1"/>
                 </a:solidFill>
               </a:rPr>
-              <a:t>[9] Anderson, H. S., &amp; Roth, P. (2018). EMBER: an open dataset for training static PE malware machine learning models. arXiv:1804.04637.</a:t>
+              <a:t>[9] Lupinacci, Blefari, Arena, &amp; Furfaro (2026). A graph-based approach for mapping kernel-level telemetry to MITRE ATT&amp;CK. arXiv:2609.12841. https://arxiv.org/abs/2609.12841</a:t>
             </a:r>
-            <a:endParaRPr lang="en-US" sz="1900" dirty="0"/>
+            <a:endParaRPr lang="en-US" sz="1800" dirty="0"/>
           </a:p>
           <a:p>
             <a:pPr algn="l" indent="0" marL="0">
@@ -18991,14 +19012,14 @@
               <a:buNone/>
             </a:pPr>
             <a:r>
-              <a:rPr lang="en-US" sz="1900" dirty="0">
+              <a:rPr lang="en-US" sz="1800" dirty="0">
                 <a:solidFill>
                   <a:schemeClr val="tx1"/>
                 </a:solidFill>
               </a:rPr>
-              <a:t>[10] Kumar, A., Kuppusamy, K. S., &amp; Aghila, G. (2019). A learning model to detect maliciousness of portable executable using integrated feature set. Journal of King Saud University: Computer and Information Sciences, 31(2). Dataset: github.com/urwithajit9/ClaMP</a:t>
+              <a:t>[10] Brahimi, B., Cohadon, V., Glazman, G., Al Mohaize, R., Berjawi, O., &amp; Khatoun, R. (2026). Delphi Scanner: efficient and interpretable static malware detection via API sequence modeling. arXiv:2609.19900. https://arxiv.org/abs/2609.19900</a:t>
             </a:r>
-            <a:endParaRPr lang="en-US" sz="1900" dirty="0"/>
+            <a:endParaRPr lang="en-US" sz="1800" dirty="0"/>
           </a:p>
         </p:txBody>
       </p:sp>
@@ -19138,14 +19159,14 @@
               <a:buNone/>
             </a:pPr>
             <a:r>
-              <a:rPr lang="en-US" sz="1900" dirty="0">
+              <a:rPr lang="en-US" sz="1800" dirty="0">
                 <a:solidFill>
                   <a:schemeClr val="tx1"/>
                 </a:solidFill>
               </a:rPr>
-              <a:t>[11] Breiman, L. (2001). Random forests. Machine Learning, 45(1), 5-32.</a:t>
+              <a:t>[11] Kumar, A., Kuppusamy, K. S., &amp; Aghila, G. (2019). A learning model to detect maliciousness of portable executable using integrated feature set (ClaMP). Journal of King Saud University: Computer and Information Sciences, 31(2). Dataset: github.com/urwithajit9/ClaMP</a:t>
             </a:r>
-            <a:endParaRPr lang="en-US" sz="1900" dirty="0"/>
+            <a:endParaRPr lang="en-US" sz="1800" dirty="0"/>
           </a:p>
           <a:p>
             <a:pPr algn="l" indent="0" marL="0">
@@ -19155,14 +19176,14 @@
               <a:buNone/>
             </a:pPr>
             <a:r>
-              <a:rPr lang="en-US" sz="1900" dirty="0">
+              <a:rPr lang="en-US" sz="1800" dirty="0">
                 <a:solidFill>
                   <a:schemeClr val="tx1"/>
                 </a:solidFill>
               </a:rPr>
-              <a:t>[12] Pedregosa, F., et al. (2011). Scikit-learn: machine learning in Python. Journal of Machine Learning Research, 12, 2825-2830.</a:t>
+              <a:t>[12] Breiman, L. (2001). Random forests. Machine Learning, 45(1), 5-32.</a:t>
             </a:r>
-            <a:endParaRPr lang="en-US" sz="1900" dirty="0"/>
+            <a:endParaRPr lang="en-US" sz="1800" dirty="0"/>
           </a:p>
           <a:p>
             <a:pPr algn="l" indent="0" marL="0">
@@ -19172,14 +19193,14 @@
               <a:buNone/>
             </a:pPr>
             <a:r>
-              <a:rPr lang="en-US" sz="1900" dirty="0">
+              <a:rPr lang="en-US" sz="1800" dirty="0">
                 <a:solidFill>
                   <a:schemeClr val="tx1"/>
                 </a:solidFill>
               </a:rPr>
-              <a:t>[13] MITRE ATT&amp;CK. Input Capture: Keylogging (T1056.001). https://attack.mitre.org/techniques/T1056/001/</a:t>
+              <a:t>[13] Pedregosa, F., et al. (2011). Scikit-learn: machine learning in Python. Journal of Machine Learning Research, 12, 2825-2830.</a:t>
             </a:r>
-            <a:endParaRPr lang="en-US" sz="1900" dirty="0"/>
+            <a:endParaRPr lang="en-US" sz="1800" dirty="0"/>
           </a:p>
           <a:p>
             <a:pPr algn="l" indent="0" marL="0">
@@ -19189,14 +19210,31 @@
               <a:buNone/>
             </a:pPr>
             <a:r>
-              <a:rPr lang="en-US" sz="1900" dirty="0">
+              <a:rPr lang="en-US" sz="1800" dirty="0">
                 <a:solidFill>
                   <a:schemeClr val="tx1"/>
                 </a:solidFill>
               </a:rPr>
-              <a:t>[14] Microsoft. SetWindowsHookExA function (winuser.h). https://learn.microsoft.com/en-us/windows/win32/api/winuser/nf-winuser-setwindowshookexa</a:t>
+              <a:t>[14] MITRE ATT&amp;CK. Input Capture: Keylogging (T1056.001). https://attack.mitre.org/techniques/T1056/001/</a:t>
             </a:r>
-            <a:endParaRPr lang="en-US" sz="1900" dirty="0"/>
+            <a:endParaRPr lang="en-US" sz="1800" dirty="0"/>
+          </a:p>
+          <a:p>
+            <a:pPr algn="l" indent="0" marL="0">
+              <a:spcAft>
+                <a:spcPts val="1000"/>
+              </a:spcAft>
+              <a:buNone/>
+            </a:pPr>
+            <a:r>
+              <a:rPr lang="en-US" sz="1800" dirty="0">
+                <a:solidFill>
+                  <a:schemeClr val="tx1"/>
+                </a:solidFill>
+              </a:rPr>
+              <a:t>[15] Microsoft. SetWindowsHookExA function (winuser.h). https://learn.microsoft.com/en-us/windows/win32/api/winuser/nf-winuser-setwindowshookexa</a:t>
+            </a:r>
+            <a:endParaRPr lang="en-US" sz="1800" dirty="0"/>
           </a:p>
         </p:txBody>
       </p:sp>
@@ -20325,7 +20363,7 @@
                             <a:schemeClr val="tx1"/>
                           </a:solidFill>
                         </a:rPr>
-                        <a:t>Bait Your Hook: A Novel Detection Technique for Keyloggers [2010]</a:t>
+                        <a:t>CBFISKD: A Combinatorial-Based Fuzzy Inference System for Keylogger Detection (base paper) [2023]</a:t>
                       </a:r>
                       <a:endParaRPr lang="en-US" sz="1800" dirty="0"/>
                     </a:p>
@@ -20387,7 +20425,7 @@
                             <a:schemeClr val="tx1"/>
                           </a:solidFill>
                         </a:rPr>
-                        <a:t>Injects bait keystrokes and checks whether a process's I/O activity correlates with them.</a:t>
+                        <a:t>Fuzzy inference system for keylogger detection that combines anomaly-based and signature-based techniques.</a:t>
                       </a:r>
                       <a:endParaRPr lang="en-US" sz="1800" dirty="0"/>
                     </a:p>
@@ -20449,7 +20487,7 @@
                             <a:schemeClr val="tx1"/>
                           </a:solidFill>
                         </a:rPr>
-                        <a:t>Needs active probing of the system</a:t>
+                        <a:t>May miss keylogger patterns it has not seen</a:t>
                       </a:r>
                       <a:endParaRPr lang="en-US" sz="1800" dirty="0"/>
                     </a:p>
@@ -20467,7 +20505,7 @@
                             <a:schemeClr val="tx1"/>
                           </a:solidFill>
                         </a:rPr>
-                        <a:t>No trust or history context</a:t>
+                        <a:t>No per-process temporal risk</a:t>
                       </a:r>
                       <a:endParaRPr lang="en-US" sz="1800" dirty="0"/>
                     </a:p>
@@ -20585,7 +20623,7 @@
                             <a:schemeClr val="tx1"/>
                           </a:solidFill>
                         </a:rPr>
-                        <a:t>KLIMAX: Profiling Memory Write Patterns to Detect Keystroke-Harvesting Malware [2011]</a:t>
+                        <a:t>Towards Trustworthy Keylogger Detection: A Comprehensive Analysis of Ensemble Techniques and Feature Selections through Explainable AI [2025]</a:t>
                       </a:r>
                       <a:endParaRPr lang="en-US" sz="1800" dirty="0"/>
                     </a:p>
@@ -20647,7 +20685,7 @@
                             <a:schemeClr val="tx1"/>
                           </a:solidFill>
                         </a:rPr>
-                        <a:t>Profiles how processes write keystroke data to memory to spot keyloggers.</a:t>
+                        <a:t>Compares 7 classifiers, 3 ensembles and 3 feature-selection methods; SHAP and LIME explain results. AdaBoost with Fisher Score reached 99.76% accuracy.</a:t>
                       </a:r>
                       <a:endParaRPr lang="en-US" sz="1800" dirty="0"/>
                     </a:p>
@@ -20709,7 +20747,7 @@
                             <a:schemeClr val="tx1"/>
                           </a:solidFill>
                         </a:rPr>
-                        <a:t>Needs runtime memory monitoring</a:t>
+                        <a:t>Public Kaggle dataset, offline classification</a:t>
                       </a:r>
                       <a:endParaRPr lang="en-US" sz="1800" dirty="0"/>
                     </a:p>
@@ -20727,7 +20765,7 @@
                             <a:schemeClr val="tx1"/>
                           </a:solidFill>
                         </a:rPr>
-                        <a:t>Dynamic evidence only</a:t>
+                        <a:t>No live process monitoring</a:t>
                       </a:r>
                       <a:endParaRPr lang="en-US" sz="1800" dirty="0"/>
                     </a:p>
@@ -21219,7 +21257,7 @@
                             <a:schemeClr val="tx1"/>
                           </a:solidFill>
                         </a:rPr>
-                        <a:t>Effective and Efficient Malware Detection at the End Host [2009]</a:t>
+                        <a:t>An Innovative Keylogger Detection System Using Machine Learning Algorithms and Dendritic Cell Algorithm [2024]</a:t>
                       </a:r>
                       <a:endParaRPr lang="en-US" sz="1800" dirty="0"/>
                     </a:p>
@@ -21281,7 +21319,7 @@
                             <a:schemeClr val="tx1"/>
                           </a:solidFill>
                         </a:rPr>
-                        <a:t>Matches system-call behavior graphs of known malware against programs at run time.</a:t>
+                        <a:t>Detects software keyloggers from the rate of input events. Hybrid SVM-NB-DCA reached 99.8% and SVM-DCA 96% accuracy.</a:t>
                       </a:r>
                       <a:endParaRPr lang="en-US" sz="1800" dirty="0"/>
                     </a:p>
@@ -21343,7 +21381,7 @@
                             <a:schemeClr val="tx1"/>
                           </a:solidFill>
                         </a:rPr>
-                        <a:t>Needs prior samples of each family</a:t>
+                        <a:t>Relies on input-rate behavior</a:t>
                       </a:r>
                       <a:endParaRPr lang="en-US" sz="1800" dirty="0"/>
                     </a:p>
@@ -21361,7 +21399,7 @@
                             <a:schemeClr val="tx1"/>
                           </a:solidFill>
                         </a:rPr>
-                        <a:t>Novel behavior can slip through</a:t>
+                        <a:t>No API or capability evidence</a:t>
                       </a:r>
                       <a:endParaRPr lang="en-US" sz="1800" dirty="0"/>
                     </a:p>
@@ -21479,7 +21517,7 @@
                             <a:schemeClr val="tx1"/>
                           </a:solidFill>
                         </a:rPr>
-                        <a:t>A Survey on Automated Dynamic Malware-Analysis Techniques and Tools [2012]</a:t>
+                        <a:t>Majority Voting Ensemble Classifier for Detecting Keylogging Attack on Internet of Things [2024]</a:t>
                       </a:r>
                       <a:endParaRPr lang="en-US" sz="1800" dirty="0"/>
                     </a:p>
@@ -21541,7 +21579,7 @@
                             <a:schemeClr val="tx1"/>
                           </a:solidFill>
                         </a:rPr>
-                        <a:t>Reviews dynamic analysis: API hooking, function-call monitoring and information-flow tracking.</a:t>
+                        <a:t>Majority-voting ensemble of CNN, RNN and LSTM on the BoT-IoT dataset improves detection and lowers false positives.</a:t>
                       </a:r>
                       <a:endParaRPr lang="en-US" sz="1800" dirty="0"/>
                     </a:p>
@@ -21603,7 +21641,7 @@
                             <a:schemeClr val="tx1"/>
                           </a:solidFill>
                         </a:rPr>
-                        <a:t>Analysis-aware malware can evade</a:t>
+                        <a:t>Targets IoT network data</a:t>
                       </a:r>
                       <a:endParaRPr lang="en-US" sz="1800" dirty="0"/>
                     </a:p>
@@ -21621,7 +21659,7 @@
                             <a:schemeClr val="tx1"/>
                           </a:solidFill>
                         </a:rPr>
-                        <a:t>Heavy for always-on monitoring</a:t>
+                        <a:t>Not Windows process behavior</a:t>
                       </a:r>
                       <a:endParaRPr lang="en-US" sz="1800" dirty="0"/>
                     </a:p>
@@ -22113,7 +22151,7 @@
                             <a:schemeClr val="tx1"/>
                           </a:solidFill>
                         </a:rPr>
-                        <a:t>Limits of Static Analysis for Malware Detection [2007]</a:t>
+                        <a:t>Explainable Malware Detection with Tailored Logic Explained Networks [2024]</a:t>
                       </a:r>
                       <a:endParaRPr lang="en-US" sz="1800" dirty="0"/>
                     </a:p>
@@ -22175,7 +22213,7 @@
                             <a:schemeClr val="tx1"/>
                           </a:solidFill>
                         </a:rPr>
-                        <a:t>Shows that code obfuscation can defeat static analysis of binaries.</a:t>
+                        <a:t>Logic Explained Networks on the EMBER dataset give first-order-logic explanations, comparable to black-box models.</a:t>
                       </a:r>
                       <a:endParaRPr lang="en-US" sz="1800" dirty="0"/>
                     </a:p>
@@ -22237,7 +22275,7 @@
                             <a:schemeClr val="tx1"/>
                           </a:solidFill>
                         </a:rPr>
-                        <a:t>Static signals alone are not conclusive</a:t>
+                        <a:t>Single-file static verdict</a:t>
                       </a:r>
                       <a:endParaRPr lang="en-US" sz="1800" dirty="0"/>
                     </a:p>
@@ -22255,7 +22293,7 @@
                             <a:schemeClr val="tx1"/>
                           </a:solidFill>
                         </a:rPr>
-                        <a:t>Motivates combining several signals</a:t>
+                        <a:t>Not keylogger-specific</a:t>
                       </a:r>
                       <a:endParaRPr lang="en-US" sz="1800" dirty="0"/>
                     </a:p>
@@ -22373,7 +22411,7 @@
                             <a:schemeClr val="tx1"/>
                           </a:solidFill>
                         </a:rPr>
-                        <a:t>PE-Miner: Mining Structural Information to Detect Malicious Executables in Realtime [2009]</a:t>
+                        <a:t>Explainable Malware Detection through Integrated Graph Reduction and Learning Techniques [2024]</a:t>
                       </a:r>
                       <a:endParaRPr lang="en-US" sz="1800" dirty="0"/>
                     </a:p>
@@ -22435,7 +22473,7 @@
                             <a:schemeClr val="tx1"/>
                           </a:solidFill>
                         </a:rPr>
-                        <a:t>Classifies executables from structural PE features such as headers, imports and resources.</a:t>
+                        <a:t>Graph neural networks on control-flow and call graphs; graph reduction plus GNNExplainer shrink graphs while keeping detection high.</a:t>
                       </a:r>
                       <a:endParaRPr lang="en-US" sz="1800" dirty="0"/>
                     </a:p>
@@ -22497,7 +22535,7 @@
                             <a:schemeClr val="tx1"/>
                           </a:solidFill>
                         </a:rPr>
-                        <a:t>General malware verdict</a:t>
+                        <a:t>Needs graph construction from binaries</a:t>
                       </a:r>
                       <a:endParaRPr lang="en-US" sz="1800" dirty="0"/>
                     </a:p>
@@ -23007,7 +23045,7 @@
                             <a:schemeClr val="tx1"/>
                           </a:solidFill>
                         </a:rPr>
-                        <a:t>Deep Neural Network Based Malware Detection Using Two-Dimensional Binary Program Features [2015]</a:t>
+                        <a:t>Ransomware Detection and Classification Using Random Forest: A Case Study with the UGRansome2024 Dataset [2024]</a:t>
                       </a:r>
                       <a:endParaRPr lang="en-US" sz="1800" dirty="0"/>
                     </a:p>
@@ -23069,7 +23107,7 @@
                             <a:schemeClr val="tx1"/>
                           </a:solidFill>
                         </a:rPr>
-                        <a:t>Feeds byte-entropy, string, import and metadata features to a deep neural network.</a:t>
+                        <a:t>Random Forest on the optimised UGRansome2024 dataset reaches about 96% classification accuracy.</a:t>
                       </a:r>
                       <a:endParaRPr lang="en-US" sz="1800" dirty="0"/>
                     </a:p>
@@ -23131,7 +23169,7 @@
                             <a:schemeClr val="tx1"/>
                           </a:solidFill>
                         </a:rPr>
-                        <a:t>Black-box model, hard to explain</a:t>
+                        <a:t>Network-traffic features</a:t>
                       </a:r>
                       <a:endParaRPr lang="en-US" sz="1800" dirty="0"/>
                     </a:p>
@@ -23149,7 +23187,7 @@
                             <a:schemeClr val="tx1"/>
                           </a:solidFill>
                         </a:rPr>
-                        <a:t>Not keylogger-specific</a:t>
+                        <a:t>Targets ransomware, not keylogging</a:t>
                       </a:r>
                       <a:endParaRPr lang="en-US" sz="1800" dirty="0"/>
                     </a:p>
@@ -23267,7 +23305,7 @@
                             <a:schemeClr val="tx1"/>
                           </a:solidFill>
                         </a:rPr>
-                        <a:t>Malware Detection by Eating a Whole EXE [2018]</a:t>
+                        <a:t>RansomTrack: A Hybrid Behavioral Analysis Framework for Ransomware Detection [2026]</a:t>
                       </a:r>
                       <a:endParaRPr lang="en-US" sz="1800" dirty="0"/>
                     </a:p>
@@ -23329,7 +23367,7 @@
                             <a:schemeClr val="tx1"/>
                           </a:solidFill>
                         </a:rPr>
-                        <a:t>Trains a convolutional network (MalConv) directly on raw executable bytes.</a:t>
+                        <a:t>Static (Radare2) and dynamic (Frida) features; XGBoost and soft voting reach about 96% accuracy, SHAP explains features.</a:t>
                       </a:r>
                       <a:endParaRPr lang="en-US" sz="1800" dirty="0"/>
                     </a:p>
@@ -23391,7 +23429,7 @@
                             <a:schemeClr val="tx1"/>
                           </a:solidFill>
                         </a:rPr>
-                        <a:t>Opaque decisions</a:t>
+                        <a:t>About 9.1 s of analysis per sample</a:t>
                       </a:r>
                       <a:endParaRPr lang="en-US" sz="1800" dirty="0"/>
                     </a:p>
@@ -23409,7 +23447,7 @@
                             <a:schemeClr val="tx1"/>
                           </a:solidFill>
                         </a:rPr>
-                        <a:t>Needs large training data</a:t>
+                        <a:t>Targets ransomware</a:t>
                       </a:r>
                       <a:endParaRPr lang="en-US" sz="1800" dirty="0"/>
                     </a:p>
@@ -23901,7 +23939,7 @@
                             <a:schemeClr val="tx1"/>
                           </a:solidFill>
                         </a:rPr>
-                        <a:t>EMBER: An Open Dataset for Training Static PE Malware Machine Learning Models [2018]</a:t>
+                        <a:t>A Graph-Based Approach for Mapping Kernel-Level Telemetry to MITRE ATT&amp;CK [2026]</a:t>
                       </a:r>
                       <a:endParaRPr lang="en-US" sz="1800" dirty="0"/>
                     </a:p>
@@ -23963,7 +24001,7 @@
                             <a:schemeClr val="tx1"/>
                           </a:solidFill>
                         </a:rPr>
-                        <a:t>Releases about 1.1 million PE files with features and a gradient-boosted baseline.</a:t>
+                        <a:t>eBPF events become provenance graphs mapped to ATT&amp;CK techniques by local LLMs; tested on 347 Atomic Red Team tests.</a:t>
                       </a:r>
                       <a:endParaRPr lang="en-US" sz="1800" dirty="0"/>
                     </a:p>
@@ -24025,7 +24063,7 @@
                             <a:schemeClr val="tx1"/>
                           </a:solidFill>
                         </a:rPr>
-                        <a:t>One file, one score</a:t>
+                        <a:t>Linux kernel telemetry</a:t>
                       </a:r>
                       <a:endParaRPr lang="en-US" sz="1800" dirty="0"/>
                     </a:p>
@@ -24043,7 +24081,7 @@
                             <a:schemeClr val="tx1"/>
                           </a:solidFill>
                         </a:rPr>
-                        <a:t>No behavior over time</a:t>
+                        <a:t>Maps behavior; does not score risk</a:t>
                       </a:r>
                       <a:endParaRPr lang="en-US" sz="1800" dirty="0"/>
                     </a:p>
@@ -24161,7 +24199,7 @@
                             <a:schemeClr val="tx1"/>
                           </a:solidFill>
                         </a:rPr>
-                        <a:t>A Learning Model to Detect Maliciousness of Portable Executable Using Integrated Feature Set (ClaMP) [2019]</a:t>
+                        <a:t>Delphi Scanner: Efficient and Interpretable Static Malware Detection via API Sequence Modeling [2026]</a:t>
                       </a:r>
                       <a:endParaRPr lang="en-US" sz="1800" dirty="0"/>
                     </a:p>
@@ -24223,7 +24261,7 @@
                             <a:schemeClr val="tx1"/>
                           </a:solidFill>
                         </a:rPr>
-                        <a:t>Combines raw and derived PE-header features; 5,210 labeled executables released publicly.</a:t>
+                        <a:t>API calls from the PE import table feed a 1D CNN: sub-millisecond inference, about 95.35% accuracy on 190,000+ PE files.</a:t>
                       </a:r>
                       <a:endParaRPr lang="en-US" sz="1800" dirty="0"/>
                     </a:p>
@@ -24285,7 +24323,7 @@
                             <a:schemeClr val="tx1"/>
                           </a:solidFill>
                         </a:rPr>
-                        <a:t>Header-based malware verdict</a:t>
+                        <a:t>Per-file triage</a:t>
                       </a:r>
                       <a:endParaRPr lang="en-US" sz="1800" dirty="0"/>
                     </a:p>
@@ -24303,7 +24341,7 @@
                             <a:schemeClr val="tx1"/>
                           </a:solidFill>
                         </a:rPr>
-                        <a:t>No keylogger or temporal context</a:t>
+                        <a:t>No temporal or keylogger-specific scoring</a:t>
                       </a:r>
                       <a:endParaRPr lang="en-US" sz="1800" dirty="0"/>
                     </a:p>

</xml_diff>

<commit_message>
Use a static image for the risk-over-time chart so it displays in all viewers
Co-Authored-By: Claude Sonnet 5.5 <noreply@anthropic.com>
Claude-Session: https://claude.ai/code/session_01Ubm72VtBiHpqSsRzfmreab
</commit_message>
<xml_diff>
--- a/presentation/Keyboard_Hook_Behavioral_Detector.pptx
+++ b/presentation/Keyboard_Hook_Behavioral_Detector.pptx
@@ -136,23 +136,23 @@
   <p:extLst>
     <p:ext uri="{521415D9-36F7-43E2-AB2F-B90AF26B5E84}">
       <p14:sectionLst xmlns:p14="http://schemas.microsoft.com/office/powerpoint/2010/main">
-        <p14:section name="Title" id="{4fa8eb9d-cb60-a882-3217-d80e26b886e8}">
+        <p14:section name="Title" id="{cabbde42-a9f2-1b00-eded-116c1527dfc0}">
           <p14:sldIdLst>
             <p14:sldId id="256"/>
             <p14:sldId id="257"/>
           </p14:sldIdLst>
         </p14:section>
-        <p14:section name="Introduction" id="{4acf0f3a-e43c-266e-bd47-f17979f9e925}">
+        <p14:section name="Introduction" id="{67cda61d-e765-bb2e-fe3c-c148c4bf5672}">
           <p14:sldIdLst>
             <p14:sldId id="258"/>
           </p14:sldIdLst>
         </p14:section>
-        <p14:section name="Problem Definition" id="{6677f4b3-2aca-c6ab-c0c8-95dce31100e2}">
+        <p14:section name="Problem Definition" id="{da612667-11ef-c5bd-5d2b-6a8698f9126e}">
           <p14:sldIdLst>
             <p14:sldId id="259"/>
           </p14:sldIdLst>
         </p14:section>
-        <p14:section name="Literature Survey" id="{87f261ed-7090-b709-b440-9cce3bb98637}">
+        <p14:section name="Literature Survey" id="{1b92af67-cdf7-8a82-75fd-4dac0e2f7904}">
           <p14:sldIdLst>
             <p14:sldId id="260"/>
             <p14:sldId id="261"/>
@@ -161,31 +161,31 @@
             <p14:sldId id="264"/>
           </p14:sldIdLst>
         </p14:section>
-        <p14:section name="Inferences" id="{b14ec87e-897c-b7a3-97af-8a1b208658a6}">
+        <p14:section name="Inferences" id="{c3cda07b-a166-5592-0805-418a8983e2d7}">
           <p14:sldIdLst>
             <p14:sldId id="265"/>
           </p14:sldIdLst>
         </p14:section>
-        <p14:section name="Proposed System" id="{71048406-da41-4a54-f065-d60ace0f59fd}">
+        <p14:section name="Proposed System" id="{fe7b271f-ea9b-316e-45f6-1fac291acc52}">
           <p14:sldIdLst>
             <p14:sldId id="266"/>
             <p14:sldId id="267"/>
           </p14:sldIdLst>
         </p14:section>
-        <p14:section name="Architecture" id="{3ecb5f1c-a4b8-e85f-5c10-5f0e2df5f8a4}">
+        <p14:section name="Architecture" id="{d643be49-d614-cf18-0040-8ad81606974e}">
           <p14:sldIdLst>
             <p14:sldId id="268"/>
             <p14:sldId id="269"/>
           </p14:sldIdLst>
         </p14:section>
-        <p14:section name="Implementation" id="{61de55c8-d2c6-c9f3-8032-4d23934d0fb3}">
+        <p14:section name="Implementation" id="{e061afa5-ec03-eac1-001b-e9fa96b1ae5a}">
           <p14:sldIdLst>
             <p14:sldId id="270"/>
             <p14:sldId id="271"/>
             <p14:sldId id="272"/>
           </p14:sldIdLst>
         </p14:section>
-        <p14:section name="Results and Discussions" id="{eebaa726-0b16-22c2-377d-40eedc5a023e}">
+        <p14:section name="Results and Discussions" id="{b23f2981-1991-5442-e26f-1075adb58f99}">
           <p14:sldIdLst>
             <p14:sldId id="273"/>
             <p14:sldId id="274"/>
@@ -197,14 +197,14 @@
             <p14:sldId id="280"/>
           </p14:sldIdLst>
         </p14:section>
-        <p14:section name="References" id="{96be746b-2fb4-a440-80e0-8969034086a2}">
+        <p14:section name="References" id="{1d5b8fb0-586c-b0cd-ddf4-51cd5578c67c}">
           <p14:sldIdLst>
             <p14:sldId id="281"/>
             <p14:sldId id="282"/>
             <p14:sldId id="283"/>
           </p14:sldIdLst>
         </p14:section>
-        <p14:section name="Conclusion" id="{8e8a139a-2ec8-0fe4-8113-09991cf83a14}">
+        <p14:section name="Conclusion" id="{c4b43c7e-13af-f982-899e-2699d621791c}">
           <p14:sldIdLst>
             <p14:sldId id="284"/>
             <p14:sldId id="285"/>
@@ -464,835 +464,6 @@
         <a:effectLst/>
       </c:spPr>
     </c:plotArea>
-    <c:plotVisOnly val="1"/>
-    <c:dispBlanksAs val="span"/>
-  </c:chart>
-  <c:spPr>
-    <a:noFill/>
-    <a:ln>
-      <a:noFill/>
-    </a:ln>
-    <a:effectLst/>
-  </c:spPr>
-  <c:externalData r:id="rId1">
-    <c:autoUpdate val="0"/>
-  </c:externalData>
-</c:chartSpace>
-</file>
-
-<file path=ppt/charts/chart2.xml><?xml version="1.0" encoding="utf-8"?>
-<c:chartSpace xmlns:c="http://schemas.openxmlformats.org/drawingml/2006/chart" xmlns:a="http://schemas.openxmlformats.org/drawingml/2006/main" xmlns:r="http://schemas.openxmlformats.org/officeDocument/2006/relationships">
-  <c:date1904 val="0"/>
-  <c:roundedCorners val="1"/>
-  <c:chart>
-    <c:autoTitleDeleted val="1"/>
-    <c:plotArea>
-      <c:layout/>
-      <c:lineChart>
-        <c:varyColors val="0"/>
-        <c:ser>
-          <c:idx val="0"/>
-          <c:order val="0"/>
-          <c:tx>
-            <c:strRef>
-              <c:f>Sheet1!$B$1</c:f>
-              <c:strCache>
-                <c:ptCount val="1"/>
-                <c:pt idx="0">
-                  <c:v>Risk score</c:v>
-                </c:pt>
-              </c:strCache>
-            </c:strRef>
-          </c:tx>
-          <c:spPr>
-            <a:solidFill>
-              <a:srgbClr val="17391B"/>
-            </a:solidFill>
-            <a:ln w="38100" cap="flat">
-              <a:solidFill>
-                <a:srgbClr val="17391B"/>
-              </a:solidFill>
-              <a:prstDash val="solid,dash,dash"/>
-              <a:round/>
-            </a:ln>
-            <a:effectLst/>
-          </c:spPr>
-          <c:invertIfNegative val="0"/>
-          <c:dLbls>
-            <c:numFmt formatCode="#,##0" sourceLinked="0"/>
-            <c:txPr>
-              <a:bodyPr/>
-              <a:lstStyle/>
-              <a:p>
-                <a:pPr>
-                  <a:defRPr b="0" i="0" strike="noStrike" sz="1200" u="none">
-                    <a:solidFill>
-                      <a:srgbClr val="000000"/>
-                    </a:solidFill>
-                    <a:latin typeface="Arial"/>
-                  </a:defRPr>
-                </a:pPr>
-              </a:p>
-            </c:txPr>
-            <c:showLegendKey val="0"/>
-            <c:showVal val="0"/>
-            <c:showCatName val="0"/>
-            <c:showSerName val="0"/>
-            <c:showPercent val="0"/>
-            <c:showBubbleSize val="0"/>
-            <c:showLeaderLines val="0"/>
-          </c:dLbls>
-          <c:marker>
-            <c:symbol val="none"/>
-            <c:size val="6"/>
-            <c:spPr>
-              <a:solidFill>
-                <a:srgbClr val="17391B"/>
-              </a:solidFill>
-              <a:ln w="9525" cap="flat">
-                <a:solidFill>
-                  <a:srgbClr val="17391B"/>
-                </a:solidFill>
-                <a:prstDash val="solid"/>
-                <a:round/>
-              </a:ln>
-              <a:effectLst/>
-            </c:spPr>
-          </c:marker>
-          <c:cat>
-            <c:multiLvlStrRef>
-              <c:f>Sheet1!$A$2:$A$19</c:f>
-              <c:multiLvlStrCache>
-                <c:ptCount val="18"/>
-                <c:lvl>
-                  <c:pt idx="0">
-                    <c:v>1</c:v>
-                  </c:pt>
-                  <c:pt idx="1">
-                    <c:v>2</c:v>
-                  </c:pt>
-                  <c:pt idx="2">
-                    <c:v>3</c:v>
-                  </c:pt>
-                  <c:pt idx="3">
-                    <c:v>4</c:v>
-                  </c:pt>
-                  <c:pt idx="4">
-                    <c:v>5</c:v>
-                  </c:pt>
-                  <c:pt idx="5">
-                    <c:v>6</c:v>
-                  </c:pt>
-                  <c:pt idx="6">
-                    <c:v>7</c:v>
-                  </c:pt>
-                  <c:pt idx="7">
-                    <c:v>8</c:v>
-                  </c:pt>
-                  <c:pt idx="8">
-                    <c:v>9</c:v>
-                  </c:pt>
-                  <c:pt idx="9">
-                    <c:v>10</c:v>
-                  </c:pt>
-                  <c:pt idx="10">
-                    <c:v>11</c:v>
-                  </c:pt>
-                  <c:pt idx="11">
-                    <c:v>12</c:v>
-                  </c:pt>
-                  <c:pt idx="12">
-                    <c:v>13</c:v>
-                  </c:pt>
-                  <c:pt idx="13">
-                    <c:v>14</c:v>
-                  </c:pt>
-                  <c:pt idx="14">
-                    <c:v>15</c:v>
-                  </c:pt>
-                  <c:pt idx="15">
-                    <c:v>16</c:v>
-                  </c:pt>
-                  <c:pt idx="16">
-                    <c:v>17</c:v>
-                  </c:pt>
-                  <c:pt idx="17">
-                    <c:v>18</c:v>
-                  </c:pt>
-                </c:lvl>
-              </c:multiLvlStrCache>
-            </c:multiLvlStrRef>
-          </c:cat>
-          <c:val>
-            <c:numRef>
-              <c:f>Sheet1!$B$2:$B$19</c:f>
-              <c:numCache>
-                <c:formatCode>General</c:formatCode>
-                <c:ptCount val="18"/>
-                <c:pt idx="0">
-                  <c:v>26</c:v>
-                </c:pt>
-                <c:pt idx="1">
-                  <c:v>47</c:v>
-                </c:pt>
-                <c:pt idx="2">
-                  <c:v>93</c:v>
-                </c:pt>
-                <c:pt idx="3">
-                  <c:v>88</c:v>
-                </c:pt>
-                <c:pt idx="4">
-                  <c:v>134</c:v>
-                </c:pt>
-                <c:pt idx="5">
-                  <c:v>129</c:v>
-                </c:pt>
-                <c:pt idx="6">
-                  <c:v>124</c:v>
-                </c:pt>
-                <c:pt idx="7">
-                  <c:v>119</c:v>
-                </c:pt>
-                <c:pt idx="8">
-                  <c:v>114</c:v>
-                </c:pt>
-                <c:pt idx="9">
-                  <c:v>109</c:v>
-                </c:pt>
-                <c:pt idx="10">
-                  <c:v>104</c:v>
-                </c:pt>
-                <c:pt idx="11">
-                  <c:v>99</c:v>
-                </c:pt>
-                <c:pt idx="12">
-                  <c:v>94</c:v>
-                </c:pt>
-                <c:pt idx="13">
-                  <c:v>89</c:v>
-                </c:pt>
-                <c:pt idx="14">
-                  <c:v>84</c:v>
-                </c:pt>
-                <c:pt idx="15">
-                  <c:v>79</c:v>
-                </c:pt>
-                <c:pt idx="16">
-                  <c:v>74</c:v>
-                </c:pt>
-                <c:pt idx="17">
-                  <c:v>69</c:v>
-                </c:pt>
-              </c:numCache>
-            </c:numRef>
-          </c:val>
-          <c:smooth val="0"/>
-        </c:ser>
-        <c:ser>
-          <c:idx val="1"/>
-          <c:order val="1"/>
-          <c:tx>
-            <c:strRef>
-              <c:f>Sheet1!$C$1</c:f>
-              <c:strCache>
-                <c:ptCount val="1"/>
-                <c:pt idx="0">
-                  <c:v>HIGH threshold (60)</c:v>
-                </c:pt>
-              </c:strCache>
-            </c:strRef>
-          </c:tx>
-          <c:spPr>
-            <a:solidFill>
-              <a:srgbClr val="A93226"/>
-            </a:solidFill>
-            <a:ln w="38100" cap="flat">
-              <a:solidFill>
-                <a:srgbClr val="A93226"/>
-              </a:solidFill>
-              <a:prstDash val="solid,dash,dash"/>
-              <a:round/>
-            </a:ln>
-            <a:effectLst/>
-          </c:spPr>
-          <c:invertIfNegative val="0"/>
-          <c:dLbls>
-            <c:numFmt formatCode="#,##0" sourceLinked="0"/>
-            <c:txPr>
-              <a:bodyPr/>
-              <a:lstStyle/>
-              <a:p>
-                <a:pPr>
-                  <a:defRPr b="0" i="0" strike="noStrike" sz="1200" u="none">
-                    <a:solidFill>
-                      <a:srgbClr val="000000"/>
-                    </a:solidFill>
-                    <a:latin typeface="Arial"/>
-                  </a:defRPr>
-                </a:pPr>
-              </a:p>
-            </c:txPr>
-            <c:showLegendKey val="0"/>
-            <c:showVal val="0"/>
-            <c:showCatName val="0"/>
-            <c:showSerName val="0"/>
-            <c:showPercent val="0"/>
-            <c:showBubbleSize val="0"/>
-            <c:showLeaderLines val="0"/>
-          </c:dLbls>
-          <c:marker>
-            <c:symbol val="none"/>
-            <c:size val="6"/>
-            <c:spPr>
-              <a:solidFill>
-                <a:srgbClr val="A93226"/>
-              </a:solidFill>
-              <a:ln w="9525" cap="flat">
-                <a:solidFill>
-                  <a:srgbClr val="A93226"/>
-                </a:solidFill>
-                <a:prstDash val="solid"/>
-                <a:round/>
-              </a:ln>
-              <a:effectLst/>
-            </c:spPr>
-          </c:marker>
-          <c:cat>
-            <c:multiLvlStrRef>
-              <c:f>Sheet1!$A$2:$A$19</c:f>
-              <c:multiLvlStrCache>
-                <c:ptCount val="18"/>
-                <c:lvl>
-                  <c:pt idx="0">
-                    <c:v>1</c:v>
-                  </c:pt>
-                  <c:pt idx="1">
-                    <c:v>2</c:v>
-                  </c:pt>
-                  <c:pt idx="2">
-                    <c:v>3</c:v>
-                  </c:pt>
-                  <c:pt idx="3">
-                    <c:v>4</c:v>
-                  </c:pt>
-                  <c:pt idx="4">
-                    <c:v>5</c:v>
-                  </c:pt>
-                  <c:pt idx="5">
-                    <c:v>6</c:v>
-                  </c:pt>
-                  <c:pt idx="6">
-                    <c:v>7</c:v>
-                  </c:pt>
-                  <c:pt idx="7">
-                    <c:v>8</c:v>
-                  </c:pt>
-                  <c:pt idx="8">
-                    <c:v>9</c:v>
-                  </c:pt>
-                  <c:pt idx="9">
-                    <c:v>10</c:v>
-                  </c:pt>
-                  <c:pt idx="10">
-                    <c:v>11</c:v>
-                  </c:pt>
-                  <c:pt idx="11">
-                    <c:v>12</c:v>
-                  </c:pt>
-                  <c:pt idx="12">
-                    <c:v>13</c:v>
-                  </c:pt>
-                  <c:pt idx="13">
-                    <c:v>14</c:v>
-                  </c:pt>
-                  <c:pt idx="14">
-                    <c:v>15</c:v>
-                  </c:pt>
-                  <c:pt idx="15">
-                    <c:v>16</c:v>
-                  </c:pt>
-                  <c:pt idx="16">
-                    <c:v>17</c:v>
-                  </c:pt>
-                  <c:pt idx="17">
-                    <c:v>18</c:v>
-                  </c:pt>
-                </c:lvl>
-              </c:multiLvlStrCache>
-            </c:multiLvlStrRef>
-          </c:cat>
-          <c:val>
-            <c:numRef>
-              <c:f>Sheet1!$C$2:$C$19</c:f>
-              <c:numCache>
-                <c:formatCode>General</c:formatCode>
-                <c:ptCount val="18"/>
-                <c:pt idx="0">
-                  <c:v>60</c:v>
-                </c:pt>
-                <c:pt idx="1">
-                  <c:v>60</c:v>
-                </c:pt>
-                <c:pt idx="2">
-                  <c:v>60</c:v>
-                </c:pt>
-                <c:pt idx="3">
-                  <c:v>60</c:v>
-                </c:pt>
-                <c:pt idx="4">
-                  <c:v>60</c:v>
-                </c:pt>
-                <c:pt idx="5">
-                  <c:v>60</c:v>
-                </c:pt>
-                <c:pt idx="6">
-                  <c:v>60</c:v>
-                </c:pt>
-                <c:pt idx="7">
-                  <c:v>60</c:v>
-                </c:pt>
-                <c:pt idx="8">
-                  <c:v>60</c:v>
-                </c:pt>
-                <c:pt idx="9">
-                  <c:v>60</c:v>
-                </c:pt>
-                <c:pt idx="10">
-                  <c:v>60</c:v>
-                </c:pt>
-                <c:pt idx="11">
-                  <c:v>60</c:v>
-                </c:pt>
-                <c:pt idx="12">
-                  <c:v>60</c:v>
-                </c:pt>
-                <c:pt idx="13">
-                  <c:v>60</c:v>
-                </c:pt>
-                <c:pt idx="14">
-                  <c:v>60</c:v>
-                </c:pt>
-                <c:pt idx="15">
-                  <c:v>60</c:v>
-                </c:pt>
-                <c:pt idx="16">
-                  <c:v>60</c:v>
-                </c:pt>
-                <c:pt idx="17">
-                  <c:v>60</c:v>
-                </c:pt>
-              </c:numCache>
-            </c:numRef>
-          </c:val>
-          <c:smooth val="0"/>
-        </c:ser>
-        <c:ser>
-          <c:idx val="2"/>
-          <c:order val="2"/>
-          <c:tx>
-            <c:strRef>
-              <c:f>Sheet1!$D$1</c:f>
-              <c:strCache>
-                <c:ptCount val="1"/>
-                <c:pt idx="0">
-                  <c:v>MEDIUM threshold (30)</c:v>
-                </c:pt>
-              </c:strCache>
-            </c:strRef>
-          </c:tx>
-          <c:spPr>
-            <a:solidFill>
-              <a:srgbClr val="B7791F"/>
-            </a:solidFill>
-            <a:ln w="38100" cap="flat">
-              <a:solidFill>
-                <a:srgbClr val="B7791F"/>
-              </a:solidFill>
-              <a:prstDash val="solid,dash,dash"/>
-              <a:round/>
-            </a:ln>
-            <a:effectLst/>
-          </c:spPr>
-          <c:invertIfNegative val="0"/>
-          <c:dLbls>
-            <c:numFmt formatCode="#,##0" sourceLinked="0"/>
-            <c:txPr>
-              <a:bodyPr/>
-              <a:lstStyle/>
-              <a:p>
-                <a:pPr>
-                  <a:defRPr b="0" i="0" strike="noStrike" sz="1200" u="none">
-                    <a:solidFill>
-                      <a:srgbClr val="000000"/>
-                    </a:solidFill>
-                    <a:latin typeface="Arial"/>
-                  </a:defRPr>
-                </a:pPr>
-              </a:p>
-            </c:txPr>
-            <c:showLegendKey val="0"/>
-            <c:showVal val="0"/>
-            <c:showCatName val="0"/>
-            <c:showSerName val="0"/>
-            <c:showPercent val="0"/>
-            <c:showBubbleSize val="0"/>
-            <c:showLeaderLines val="0"/>
-          </c:dLbls>
-          <c:marker>
-            <c:symbol val="none"/>
-            <c:size val="6"/>
-            <c:spPr>
-              <a:solidFill>
-                <a:srgbClr val="B7791F"/>
-              </a:solidFill>
-              <a:ln w="9525" cap="flat">
-                <a:solidFill>
-                  <a:srgbClr val="B7791F"/>
-                </a:solidFill>
-                <a:prstDash val="solid"/>
-                <a:round/>
-              </a:ln>
-              <a:effectLst/>
-            </c:spPr>
-          </c:marker>
-          <c:cat>
-            <c:multiLvlStrRef>
-              <c:f>Sheet1!$A$2:$A$19</c:f>
-              <c:multiLvlStrCache>
-                <c:ptCount val="18"/>
-                <c:lvl>
-                  <c:pt idx="0">
-                    <c:v>1</c:v>
-                  </c:pt>
-                  <c:pt idx="1">
-                    <c:v>2</c:v>
-                  </c:pt>
-                  <c:pt idx="2">
-                    <c:v>3</c:v>
-                  </c:pt>
-                  <c:pt idx="3">
-                    <c:v>4</c:v>
-                  </c:pt>
-                  <c:pt idx="4">
-                    <c:v>5</c:v>
-                  </c:pt>
-                  <c:pt idx="5">
-                    <c:v>6</c:v>
-                  </c:pt>
-                  <c:pt idx="6">
-                    <c:v>7</c:v>
-                  </c:pt>
-                  <c:pt idx="7">
-                    <c:v>8</c:v>
-                  </c:pt>
-                  <c:pt idx="8">
-                    <c:v>9</c:v>
-                  </c:pt>
-                  <c:pt idx="9">
-                    <c:v>10</c:v>
-                  </c:pt>
-                  <c:pt idx="10">
-                    <c:v>11</c:v>
-                  </c:pt>
-                  <c:pt idx="11">
-                    <c:v>12</c:v>
-                  </c:pt>
-                  <c:pt idx="12">
-                    <c:v>13</c:v>
-                  </c:pt>
-                  <c:pt idx="13">
-                    <c:v>14</c:v>
-                  </c:pt>
-                  <c:pt idx="14">
-                    <c:v>15</c:v>
-                  </c:pt>
-                  <c:pt idx="15">
-                    <c:v>16</c:v>
-                  </c:pt>
-                  <c:pt idx="16">
-                    <c:v>17</c:v>
-                  </c:pt>
-                  <c:pt idx="17">
-                    <c:v>18</c:v>
-                  </c:pt>
-                </c:lvl>
-              </c:multiLvlStrCache>
-            </c:multiLvlStrRef>
-          </c:cat>
-          <c:val>
-            <c:numRef>
-              <c:f>Sheet1!$D$2:$D$19</c:f>
-              <c:numCache>
-                <c:formatCode>General</c:formatCode>
-                <c:ptCount val="18"/>
-                <c:pt idx="0">
-                  <c:v>30</c:v>
-                </c:pt>
-                <c:pt idx="1">
-                  <c:v>30</c:v>
-                </c:pt>
-                <c:pt idx="2">
-                  <c:v>30</c:v>
-                </c:pt>
-                <c:pt idx="3">
-                  <c:v>30</c:v>
-                </c:pt>
-                <c:pt idx="4">
-                  <c:v>30</c:v>
-                </c:pt>
-                <c:pt idx="5">
-                  <c:v>30</c:v>
-                </c:pt>
-                <c:pt idx="6">
-                  <c:v>30</c:v>
-                </c:pt>
-                <c:pt idx="7">
-                  <c:v>30</c:v>
-                </c:pt>
-                <c:pt idx="8">
-                  <c:v>30</c:v>
-                </c:pt>
-                <c:pt idx="9">
-                  <c:v>30</c:v>
-                </c:pt>
-                <c:pt idx="10">
-                  <c:v>30</c:v>
-                </c:pt>
-                <c:pt idx="11">
-                  <c:v>30</c:v>
-                </c:pt>
-                <c:pt idx="12">
-                  <c:v>30</c:v>
-                </c:pt>
-                <c:pt idx="13">
-                  <c:v>30</c:v>
-                </c:pt>
-                <c:pt idx="14">
-                  <c:v>30</c:v>
-                </c:pt>
-                <c:pt idx="15">
-                  <c:v>30</c:v>
-                </c:pt>
-                <c:pt idx="16">
-                  <c:v>30</c:v>
-                </c:pt>
-                <c:pt idx="17">
-                  <c:v>30</c:v>
-                </c:pt>
-              </c:numCache>
-            </c:numRef>
-          </c:val>
-          <c:smooth val="0"/>
-        </c:ser>
-        <c:dLbls>
-          <c:numFmt formatCode="#,##0" sourceLinked="0"/>
-          <c:txPr>
-            <a:bodyPr/>
-            <a:lstStyle/>
-            <a:p>
-              <a:pPr>
-                <a:defRPr b="0" i="0" strike="noStrike" sz="1200" u="none">
-                  <a:solidFill>
-                    <a:srgbClr val="000000"/>
-                  </a:solidFill>
-                  <a:latin typeface="Arial"/>
-                </a:defRPr>
-              </a:pPr>
-            </a:p>
-          </c:txPr>
-          <c:showLegendKey val="0"/>
-          <c:showVal val="0"/>
-          <c:showCatName val="0"/>
-          <c:showSerName val="0"/>
-          <c:showPercent val="0"/>
-          <c:showBubbleSize val="0"/>
-          <c:showLeaderLines val="0"/>
-        </c:dLbls>
-        <c:marker val="1"/>
-        <c:axId val="2094734554"/>
-        <c:axId val="2094734552"/>
-        <c:axId val="2094734556"/>
-      </c:lineChart>
-      <c:catAx>
-        <c:axId val="2094734554"/>
-        <c:scaling>
-          <c:orientation val="minMax"/>
-        </c:scaling>
-        <c:delete val="0"/>
-        <c:axPos val="b"/>
-        <c:title>
-          <c:tx>
-            <c:rich>
-              <a:bodyPr/>
-              <a:lstStyle/>
-              <a:p>
-                <a:pPr>
-                  <a:defRPr sz="1300" b="0" i="0" u="none" strike="noStrike">
-                    <a:solidFill>
-                      <a:srgbClr val="17391B"/>
-                    </a:solidFill>
-                    <a:latin typeface="+mn-lt"/>
-                  </a:defRPr>
-                </a:pPr>
-                <a:r>
-                  <a:rPr sz="1300" b="0" i="0" u="none" strike="noStrike">
-                    <a:solidFill>
-                      <a:srgbClr val="17391B"/>
-                    </a:solidFill>
-                    <a:latin typeface="+mn-lt"/>
-                  </a:rPr>
-                  <a:t>Analysis cycle</a:t>
-                </a:r>
-              </a:p>
-            </c:rich>
-          </c:tx>
-          <c:layout/>
-          <c:overlay val="0"/>
-        </c:title>
-        <c:numFmt formatCode="General" sourceLinked="1"/>
-        <c:majorTickMark val="out"/>
-        <c:minorTickMark val="none"/>
-        <c:tickLblPos val="low"/>
-        <c:spPr>
-          <a:ln w="12700" cap="flat">
-            <a:solidFill>
-              <a:srgbClr val="888888"/>
-            </a:solidFill>
-            <a:prstDash val="solid"/>
-            <a:round/>
-          </a:ln>
-        </c:spPr>
-        <c:txPr>
-          <a:bodyPr/>
-          <a:lstStyle/>
-          <a:p>
-            <a:pPr>
-              <a:defRPr sz="1300" b="0" i="0" u="none" strike="noStrike">
-                <a:solidFill>
-                  <a:srgbClr val="17391B"/>
-                </a:solidFill>
-                <a:latin typeface="+mn-lt"/>
-              </a:defRPr>
-            </a:pPr>
-            <a:endParaRPr lang="en-US"/>
-          </a:p>
-        </c:txPr>
-        <c:crossAx val="2094734552"/>
-        <c:crosses val="autoZero"/>
-        <c:auto val="1"/>
-        <c:lblAlgn val="ctr"/>
-        <c:noMultiLvlLbl val="1"/>
-      </c:catAx>
-      <c:valAx>
-        <c:axId val="2094734552"/>
-        <c:scaling>
-          <c:orientation val="minMax"/>
-          <c:max val="150"/>
-          <c:min val="0"/>
-        </c:scaling>
-        <c:delete val="0"/>
-        <c:axPos val="l"/>
-        <c:majorGridlines>
-          <c:spPr>
-            <a:ln w="9525" cap="flat">
-              <a:solidFill>
-                <a:srgbClr val="C9CEC6"/>
-              </a:solidFill>
-              <a:prstDash val="solid"/>
-              <a:round/>
-            </a:ln>
-          </c:spPr>
-        </c:majorGridlines>
-        <c:title>
-          <c:tx>
-            <c:rich>
-              <a:bodyPr/>
-              <a:lstStyle/>
-              <a:p>
-                <a:pPr>
-                  <a:defRPr sz="1300" b="0" i="0" u="none" strike="noStrike">
-                    <a:solidFill>
-                      <a:srgbClr val="17391B"/>
-                    </a:solidFill>
-                    <a:latin typeface="+mn-lt"/>
-                  </a:defRPr>
-                </a:pPr>
-                <a:r>
-                  <a:rPr sz="1300" b="0" i="0" u="none" strike="noStrike">
-                    <a:solidFill>
-                      <a:srgbClr val="17391B"/>
-                    </a:solidFill>
-                    <a:latin typeface="+mn-lt"/>
-                  </a:rPr>
-                  <a:t>Risk score</a:t>
-                </a:r>
-              </a:p>
-            </c:rich>
-          </c:tx>
-          <c:layout/>
-          <c:overlay val="0"/>
-        </c:title>
-        <c:numFmt formatCode="General" sourceLinked="0"/>
-        <c:majorTickMark val="out"/>
-        <c:minorTickMark val="none"/>
-        <c:tickLblPos val="nextTo"/>
-        <c:spPr>
-          <a:ln w="12700" cap="flat">
-            <a:solidFill>
-              <a:srgbClr val="888888"/>
-            </a:solidFill>
-            <a:prstDash val="solid"/>
-            <a:round/>
-          </a:ln>
-        </c:spPr>
-        <c:txPr>
-          <a:bodyPr/>
-          <a:lstStyle/>
-          <a:p>
-            <a:pPr>
-              <a:defRPr sz="1300" b="0" i="0" u="none" strike="noStrike">
-                <a:solidFill>
-                  <a:srgbClr val="17391B"/>
-                </a:solidFill>
-                <a:latin typeface="+mn-lt"/>
-              </a:defRPr>
-            </a:pPr>
-            <a:endParaRPr lang="en-US"/>
-          </a:p>
-        </c:txPr>
-        <c:crossAx val="2094734554"/>
-        <c:crosses val="autoZero"/>
-        <c:crossBetween val="between"/>
-        <c:majorUnit val="30"/>
-      </c:valAx>
-      <c:spPr>
-        <a:noFill/>
-        <a:ln>
-          <a:noFill/>
-        </a:ln>
-        <a:effectLst/>
-      </c:spPr>
-    </c:plotArea>
-    <c:legend>
-      <c:legendPos val="b"/>
-      <c:overlay val="0"/>
-      <c:txPr>
-        <a:bodyPr/>
-        <a:lstStyle/>
-        <a:p>
-          <a:pPr>
-            <a:defRPr sz="1300">
-              <a:solidFill>
-                <a:srgbClr val="17391B"/>
-              </a:solidFill>
-              <a:latin typeface="+mn-lt"/>
-              <a:cs typeface="+mn-lt"/>
-            </a:defRPr>
-          </a:pPr>
-          <a:endParaRPr lang="en-US"/>
-        </a:p>
-      </c:txPr>
-    </c:legend>
     <c:plotVisOnly val="1"/>
     <c:dispBlanksAs val="span"/>
   </c:chart>
@@ -18113,22 +17284,30 @@
           </a:p>
         </p:txBody>
       </p:sp>
-      <p:graphicFrame>
-        <p:nvGraphicFramePr>
-          <p:cNvPr id="3" name="Chart 0" descr=""/>
-          <p:cNvGraphicFramePr/>
+      <p:pic>
+        <p:nvPicPr>
+          <p:cNvPr id="3" name="Risk over time chart" descr="Line chart: simulated risk score over 18 analysis cycles against the MEDIUM (30) and HIGH (60) thresholds">    </p:cNvPr>
+          <p:cNvPicPr>
+            <a:picLocks noChangeAspect="1"/>
+          </p:cNvPicPr>
           <p:nvPr/>
-        </p:nvGraphicFramePr>
-        <p:xfrm>
-          <a:off x="914400" y="1234440"/>
-          <a:ext cx="10332720" cy="4343400"/>
-        </p:xfrm>
-        <a:graphic xmlns:a="http://schemas.openxmlformats.org/drawingml/2006/main">
-          <a:graphicData uri="http://schemas.openxmlformats.org/drawingml/2006/chart">
-            <c:chart xmlns:c="http://schemas.openxmlformats.org/drawingml/2006/chart" r:id="rId1"/>
-          </a:graphicData>
-        </a:graphic>
-      </p:graphicFrame>
+        </p:nvPicPr>
+        <p:blipFill>
+          <a:blip r:embed="rId1"/>
+          <a:stretch>
+            <a:fillRect/>
+          </a:stretch>
+        </p:blipFill>
+        <p:spPr>
+          <a:xfrm>
+            <a:off x="914400" y="1234440"/>
+            <a:ext cx="10332720" cy="4343400"/>
+          </a:xfrm>
+          <a:prstGeom prst="rect">
+            <a:avLst/>
+          </a:prstGeom>
+        </p:spPr>
+      </p:pic>
       <p:sp>
         <p:nvSpPr>
           <p:cNvPr id="4" name="Caption"/>

</xml_diff>